<commit_message>
Proyecto UrbanJungle - Fase 2
Implementación de ERP, SCM y CRM en Odoo para UrbanJungle:
Productos.xlsx con 20 productos, scripts de carga a la instancia
(20 proveedores, 30 clientes, 50 ventas con entrega, reglas de
reordenamiento, pipeline y plantillas de correo), recursos gráficos,
Manual Técnico en DOCX y PDF, y el zip de entrega [SOG1]Fase2_G3.zip.

Incluye los cambios finales de la Fase 1: nombres del equipo en la
presentación, PDFs regenerados y el zip [SOG1]Fase1_G3.zip.
</commit_message>
<xml_diff>
--- a/Presentacion_UrbanJungle.pptx
+++ b/Presentacion_UrbanJungle.pptx
@@ -2382,8 +2382,8 @@
         </p:nvSpPr>
         <p:spPr>
           <a:xfrm>
-            <a:off x="822960" y="5074920"/>
-            <a:ext cx="3657600" cy="566928"/>
+            <a:off x="822960" y="4892040"/>
+            <a:ext cx="3657600" cy="530352"/>
           </a:xfrm>
           <a:prstGeom prst="roundRect">
             <a:avLst>
@@ -2404,8 +2404,8 @@
         </p:nvSpPr>
         <p:spPr>
           <a:xfrm>
-            <a:off x="822960" y="5074920"/>
-            <a:ext cx="3657600" cy="566928"/>
+            <a:off x="822960" y="4892040"/>
+            <a:ext cx="3657600" cy="530352"/>
           </a:xfrm>
           <a:prstGeom prst="rect">
             <a:avLst/>
@@ -2443,7 +2443,7 @@
         </p:nvSpPr>
         <p:spPr>
           <a:xfrm>
-            <a:off x="822960" y="6355080"/>
+            <a:off x="822960" y="5669280"/>
             <a:ext cx="7315200" cy="274320"/>
           </a:xfrm>
           <a:prstGeom prst="rect">
@@ -2460,15 +2460,249 @@
               <a:buNone/>
             </a:pPr>
             <a:r>
+              <a:rPr lang="en-US" sz="1200" b="1" spc="200" kern="0" dirty="0">
+                <a:solidFill>
+                  <a:srgbClr val="5FA37A"/>
+                </a:solidFill>
+                <a:latin typeface="Calibri" pitchFamily="34" charset="0"/>
+                <a:ea typeface="Calibri" pitchFamily="34" charset="-122"/>
+                <a:cs typeface="Calibri" pitchFamily="34" charset="-120"/>
+              </a:rPr>
+              <a:t>GRUPO 3</a:t>
+            </a:r>
+            <a:endParaRPr lang="en-US" sz="1200" dirty="0"/>
+          </a:p>
+        </p:txBody>
+      </p:sp>
+      <p:sp>
+        <p:nvSpPr>
+          <p:cNvPr id="10" name="Text 8"/>
+          <p:cNvSpPr txBox="1"/>
+          <p:nvPr/>
+        </p:nvSpPr>
+        <p:spPr>
+          <a:xfrm>
+            <a:off x="822960" y="5989320"/>
+            <a:ext cx="3383280" cy="365760"/>
+          </a:xfrm>
+          <a:prstGeom prst="rect">
+            <a:avLst/>
+          </a:prstGeom>
+          <a:noFill/>
+          <a:ln/>
+        </p:spPr>
+        <p:txBody>
+          <a:bodyPr wrap="square" lIns="0" tIns="0" rIns="0" bIns="0" rtlCol="0" anchor="ctr"/>
+          <a:lstStyle/>
+          <a:p>
+            <a:pPr indent="0" marL="0">
+              <a:buNone/>
+            </a:pPr>
+            <a:r>
+              <a:rPr lang="en-US" sz="1300" b="1" dirty="0">
+                <a:solidFill>
+                  <a:srgbClr val="FFFFFF"/>
+                </a:solidFill>
+                <a:latin typeface="Calibri" pitchFamily="34" charset="0"/>
+                <a:ea typeface="Calibri" pitchFamily="34" charset="-122"/>
+                <a:cs typeface="Calibri" pitchFamily="34" charset="-120"/>
+              </a:rPr>
+              <a:t>Hernán Ricardo Ávila Castillo</a:t>
+            </a:r>
+            <a:endParaRPr lang="en-US" sz="1300" dirty="0"/>
+          </a:p>
+        </p:txBody>
+      </p:sp>
+      <p:sp>
+        <p:nvSpPr>
+          <p:cNvPr id="11" name="Text 9"/>
+          <p:cNvSpPr txBox="1"/>
+          <p:nvPr/>
+        </p:nvSpPr>
+        <p:spPr>
+          <a:xfrm>
+            <a:off x="822960" y="6327648"/>
+            <a:ext cx="3383280" cy="274320"/>
+          </a:xfrm>
+          <a:prstGeom prst="rect">
+            <a:avLst/>
+          </a:prstGeom>
+          <a:noFill/>
+          <a:ln/>
+        </p:spPr>
+        <p:txBody>
+          <a:bodyPr wrap="square" lIns="0" tIns="0" rIns="0" bIns="0" rtlCol="0" anchor="ctr"/>
+          <a:lstStyle/>
+          <a:p>
+            <a:pPr indent="0" marL="0">
+              <a:buNone/>
+            </a:pPr>
+            <a:r>
               <a:rPr lang="en-US" sz="1100" dirty="0">
                 <a:solidFill>
-                  <a:srgbClr val="6FA98A"/>
-                </a:solidFill>
-                <a:latin typeface="Calibri" pitchFamily="34" charset="0"/>
-                <a:ea typeface="Calibri" pitchFamily="34" charset="-122"/>
-                <a:cs typeface="Calibri" pitchFamily="34" charset="-120"/>
-              </a:rPr>
-              <a:t>Grupo No. ____  ·  Integrantes: (completar)</a:t>
+                  <a:srgbClr val="8FBFA2"/>
+                </a:solidFill>
+                <a:latin typeface="Calibri" pitchFamily="34" charset="0"/>
+                <a:ea typeface="Calibri" pitchFamily="34" charset="-122"/>
+                <a:cs typeface="Calibri" pitchFamily="34" charset="-120"/>
+              </a:rPr>
+              <a:t>Carné 9516085</a:t>
+            </a:r>
+            <a:endParaRPr lang="en-US" sz="1100" dirty="0"/>
+          </a:p>
+        </p:txBody>
+      </p:sp>
+      <p:sp>
+        <p:nvSpPr>
+          <p:cNvPr id="12" name="Text 10"/>
+          <p:cNvSpPr txBox="1"/>
+          <p:nvPr/>
+        </p:nvSpPr>
+        <p:spPr>
+          <a:xfrm>
+            <a:off x="4443984" y="5989320"/>
+            <a:ext cx="3383280" cy="365760"/>
+          </a:xfrm>
+          <a:prstGeom prst="rect">
+            <a:avLst/>
+          </a:prstGeom>
+          <a:noFill/>
+          <a:ln/>
+        </p:spPr>
+        <p:txBody>
+          <a:bodyPr wrap="square" lIns="0" tIns="0" rIns="0" bIns="0" rtlCol="0" anchor="ctr"/>
+          <a:lstStyle/>
+          <a:p>
+            <a:pPr indent="0" marL="0">
+              <a:buNone/>
+            </a:pPr>
+            <a:r>
+              <a:rPr lang="en-US" sz="1300" b="1" dirty="0">
+                <a:solidFill>
+                  <a:srgbClr val="FFFFFF"/>
+                </a:solidFill>
+                <a:latin typeface="Calibri" pitchFamily="34" charset="0"/>
+                <a:ea typeface="Calibri" pitchFamily="34" charset="-122"/>
+                <a:cs typeface="Calibri" pitchFamily="34" charset="-120"/>
+              </a:rPr>
+              <a:t>Sebastián Gómez Lavarreda</a:t>
+            </a:r>
+            <a:endParaRPr lang="en-US" sz="1300" dirty="0"/>
+          </a:p>
+        </p:txBody>
+      </p:sp>
+      <p:sp>
+        <p:nvSpPr>
+          <p:cNvPr id="13" name="Text 11"/>
+          <p:cNvSpPr txBox="1"/>
+          <p:nvPr/>
+        </p:nvSpPr>
+        <p:spPr>
+          <a:xfrm>
+            <a:off x="4443984" y="6327648"/>
+            <a:ext cx="3383280" cy="274320"/>
+          </a:xfrm>
+          <a:prstGeom prst="rect">
+            <a:avLst/>
+          </a:prstGeom>
+          <a:noFill/>
+          <a:ln/>
+        </p:spPr>
+        <p:txBody>
+          <a:bodyPr wrap="square" lIns="0" tIns="0" rIns="0" bIns="0" rtlCol="0" anchor="ctr"/>
+          <a:lstStyle/>
+          <a:p>
+            <a:pPr indent="0" marL="0">
+              <a:buNone/>
+            </a:pPr>
+            <a:r>
+              <a:rPr lang="en-US" sz="1100" dirty="0">
+                <a:solidFill>
+                  <a:srgbClr val="8FBFA2"/>
+                </a:solidFill>
+                <a:latin typeface="Calibri" pitchFamily="34" charset="0"/>
+                <a:ea typeface="Calibri" pitchFamily="34" charset="-122"/>
+                <a:cs typeface="Calibri" pitchFamily="34" charset="-120"/>
+              </a:rPr>
+              <a:t>Carné 201602929</a:t>
+            </a:r>
+            <a:endParaRPr lang="en-US" sz="1100" dirty="0"/>
+          </a:p>
+        </p:txBody>
+      </p:sp>
+      <p:sp>
+        <p:nvSpPr>
+          <p:cNvPr id="14" name="Text 12"/>
+          <p:cNvSpPr txBox="1"/>
+          <p:nvPr/>
+        </p:nvSpPr>
+        <p:spPr>
+          <a:xfrm>
+            <a:off x="8065008" y="5989320"/>
+            <a:ext cx="3383280" cy="365760"/>
+          </a:xfrm>
+          <a:prstGeom prst="rect">
+            <a:avLst/>
+          </a:prstGeom>
+          <a:noFill/>
+          <a:ln/>
+        </p:spPr>
+        <p:txBody>
+          <a:bodyPr wrap="square" lIns="0" tIns="0" rIns="0" bIns="0" rtlCol="0" anchor="ctr"/>
+          <a:lstStyle/>
+          <a:p>
+            <a:pPr indent="0" marL="0">
+              <a:buNone/>
+            </a:pPr>
+            <a:r>
+              <a:rPr lang="en-US" sz="1300" b="1" dirty="0">
+                <a:solidFill>
+                  <a:srgbClr val="FFFFFF"/>
+                </a:solidFill>
+                <a:latin typeface="Calibri" pitchFamily="34" charset="0"/>
+                <a:ea typeface="Calibri" pitchFamily="34" charset="-122"/>
+                <a:cs typeface="Calibri" pitchFamily="34" charset="-120"/>
+              </a:rPr>
+              <a:t>Rodrigo Alejandro Tahuite Soria</a:t>
+            </a:r>
+            <a:endParaRPr lang="en-US" sz="1300" dirty="0"/>
+          </a:p>
+        </p:txBody>
+      </p:sp>
+      <p:sp>
+        <p:nvSpPr>
+          <p:cNvPr id="15" name="Text 13"/>
+          <p:cNvSpPr txBox="1"/>
+          <p:nvPr/>
+        </p:nvSpPr>
+        <p:spPr>
+          <a:xfrm>
+            <a:off x="8065008" y="6327648"/>
+            <a:ext cx="3383280" cy="274320"/>
+          </a:xfrm>
+          <a:prstGeom prst="rect">
+            <a:avLst/>
+          </a:prstGeom>
+          <a:noFill/>
+          <a:ln/>
+        </p:spPr>
+        <p:txBody>
+          <a:bodyPr wrap="square" lIns="0" tIns="0" rIns="0" bIns="0" rtlCol="0" anchor="ctr"/>
+          <a:lstStyle/>
+          <a:p>
+            <a:pPr indent="0" marL="0">
+              <a:buNone/>
+            </a:pPr>
+            <a:r>
+              <a:rPr lang="en-US" sz="1100" dirty="0">
+                <a:solidFill>
+                  <a:srgbClr val="8FBFA2"/>
+                </a:solidFill>
+                <a:latin typeface="Calibri" pitchFamily="34" charset="0"/>
+                <a:ea typeface="Calibri" pitchFamily="34" charset="-122"/>
+                <a:cs typeface="Calibri" pitchFamily="34" charset="-120"/>
+              </a:rPr>
+              <a:t>Carné 202202854</a:t>
             </a:r>
             <a:endParaRPr lang="en-US" sz="1100" dirty="0"/>
           </a:p>

</xml_diff>